<commit_message>
feat(deck): redo slides 02 and 09 with the AI-first bridge and next steps
- replace Simone's pain-points slide with a generated one: three pains, arrow, AI-first bridge panel
- replace the founders slide with Where we stand: four-step track and the mission band
- assembler drops Simone's slide 2 and gives the new slide 09 the Conclusion nav pill
- add HTML drafts, pain icons, Canva exports, handoff sections 12 and 13, README update
</commit_message>
<xml_diff>
--- a/fable-andi/pitch/strategy-slides.pptx
+++ b/fable-andi/pitch/strategy-slides.pptx
@@ -10,9 +10,10 @@
     <p:sldId id="258" r:id="rId4"/>
     <p:sldId id="259" r:id="rId5"/>
     <p:sldId id="260" r:id="rId6"/>
+    <p:sldId id="261" r:id="rId7"/>
   </p:sldIdLst>
   <p:notesMasterIdLst>
-    <p:notesMasterId r:id="rId7"/>
+    <p:notesMasterId r:id="rId8"/>
   </p:notesMasterIdLst>
   <p:sldSz cx="18288000" cy="10287000"/>
   <p:notesSz cx="10287000" cy="18288000"/>
@@ -858,7 +859,7 @@
           <a:p>
             <a:r>
               <a:rPr lang="en-US" dirty="0"/>
-              <a:t>Founder-problem fit: Andreas builds the kind of system the product is; Simone owns customers and partners, which is what year one needs. Stage: live website, designed collector, researched legal map, legal model under verification, no customer yet, no firm signed.</a:t>
+              <a:t>Now: product blueprint in planning; legal model validated country by country (planned as a project in a law class at ELTE, Budapest; submission not yet confirmed, so ELTE stays off the slide). AI Entrepreneurs Lab: build the MVP (evidence graph, adviser, legal gate). Launch: NIS2 readiness in the Netherlands; customers and law firm partners are won in parallel, neither waits for the other. Grow: Sweden, Germany as a country pack, further regulations. No dates on the slide by decision.</a:t>
             </a:r>
             <a:endParaRPr lang="en-US" dirty="0"/>
           </a:p>
@@ -882,6 +883,94 @@
             <a:fld id="{F7021451-1387-4CA6-816F-3879F97B5CBC}" type="slidenum">
               <a:rPr lang="en-US"/>
               <a:t>5</a:t>
+            </a:fld>
+            <a:endParaRPr lang="en-US"/>
+          </a:p>
+        </p:txBody>
+      </p:sp>
+    </p:spTree>
+    <p:extLst>
+      <p:ext uri="{BB962C8B-B14F-4D97-AF65-F5344CB8AC3E}">
+        <p14:creationId xmlns:p14="http://schemas.microsoft.com/office/powerpoint/2010/main" val="1024086991"/>
+      </p:ext>
+    </p:extLst>
+  </p:cSld>
+  <p:clrMapOvr>
+    <a:masterClrMapping/>
+  </p:clrMapOvr>
+</p:notes>
+</file>
+
+<file path=ppt/notesSlides/notesSlide6.xml><?xml version="1.0" encoding="utf-8"?>
+<p:notes xmlns:a="http://schemas.openxmlformats.org/drawingml/2006/main" xmlns:r="http://schemas.openxmlformats.org/officeDocument/2006/relationships" xmlns:p="http://schemas.openxmlformats.org/presentationml/2006/main">
+  <p:cSld>
+    <p:spTree>
+      <p:nvGrpSpPr>
+        <p:cNvPr id="1" name=""/>
+        <p:cNvGrpSpPr/>
+        <p:nvPr/>
+      </p:nvGrpSpPr>
+      <p:grpSpPr>
+        <a:xfrm>
+          <a:off x="0" y="0"/>
+          <a:ext cx="0" cy="0"/>
+          <a:chOff x="0" y="0"/>
+          <a:chExt cx="0" cy="0"/>
+        </a:xfrm>
+      </p:grpSpPr>
+      <p:sp>
+        <p:nvSpPr>
+          <p:cNvPr id="2" name="Slide Image Placeholder 1"/>
+          <p:cNvSpPr>
+            <a:spLocks noGrp="1" noRot="1" noChangeAspect="1"/>
+          </p:cNvSpPr>
+          <p:nvPr>
+            <p:ph type="sldImg"/>
+          </p:nvPr>
+        </p:nvSpPr>
+        <p:spPr/>
+      </p:sp>
+      <p:sp>
+        <p:nvSpPr>
+          <p:cNvPr id="3" name="Notes Placeholder 2"/>
+          <p:cNvSpPr>
+            <a:spLocks noGrp="1"/>
+          </p:cNvSpPr>
+          <p:nvPr>
+            <p:ph type="body" idx="1"/>
+          </p:nvPr>
+        </p:nvSpPr>
+        <p:spPr/>
+        <p:txBody>
+          <a:bodyPr/>
+          <a:lstStyle/>
+          <a:p>
+            <a:r>
+              <a:rPr lang="en-US" dirty="0"/>
+              <a:t>Three pains as on Simone's slide. The bridge: AI-first compliance, the facts come from the company's systems, not from questionnaires. Hands over to slide 03, the inside out framework.</a:t>
+            </a:r>
+            <a:endParaRPr lang="en-US" dirty="0"/>
+          </a:p>
+        </p:txBody>
+      </p:sp>
+      <p:sp>
+        <p:nvSpPr>
+          <p:cNvPr id="4" name="Slide Number Placeholder 3"/>
+          <p:cNvSpPr>
+            <a:spLocks noGrp="1"/>
+          </p:cNvSpPr>
+          <p:nvPr>
+            <p:ph type="sldNum" sz="quarter" idx="10"/>
+          </p:nvPr>
+        </p:nvSpPr>
+        <p:spPr/>
+        <p:txBody>
+          <a:bodyPr/>
+          <a:lstStyle/>
+          <a:p>
+            <a:fld id="{F7021451-1387-4CA6-816F-3879F97B5CBC}" type="slidenum">
+              <a:rPr lang="en-US"/>
+              <a:t>6</a:t>
             </a:fld>
             <a:endParaRPr lang="en-US"/>
           </a:p>
@@ -17026,7 +17115,7 @@
                 <a:ea typeface="Poppins" pitchFamily="34" charset="-122"/>
                 <a:cs typeface="Poppins" pitchFamily="34" charset="-120"/>
               </a:rPr>
-              <a:t>TEAM</a:t>
+              <a:t>NEXT STEPS</a:t>
             </a:r>
             <a:endParaRPr lang="en-US" sz="1700" dirty="0"/>
           </a:p>
@@ -17065,7 +17154,7 @@
                 <a:ea typeface="Poppins" pitchFamily="34" charset="-122"/>
                 <a:cs typeface="Poppins" pitchFamily="34" charset="-120"/>
               </a:rPr>
-              <a:t>WHY </a:t>
+              <a:t>WHERE WE </a:t>
             </a:r>
             <a:pPr indent="0" marL="0">
               <a:buNone/>
@@ -17079,7 +17168,7 @@
                 <a:ea typeface="Poppins" pitchFamily="34" charset="-122"/>
                 <a:cs typeface="Poppins" pitchFamily="34" charset="-120"/>
               </a:rPr>
-              <a:t>US.</a:t>
+              <a:t>STAND.</a:t>
             </a:r>
             <a:endParaRPr lang="en-US" sz="5300" dirty="0"/>
           </a:p>
@@ -17118,7 +17207,7 @@
                 <a:ea typeface="Poppins" pitchFamily="34" charset="-122"/>
                 <a:cs typeface="Poppins" pitchFamily="34" charset="-120"/>
               </a:rPr>
-              <a:t>We have met this problem at work. Now we build the way out of it.</a:t>
+              <a:t>Plan and validate first. Then build, launch, grow.</a:t>
             </a:r>
             <a:endParaRPr lang="en-US" sz="1950" dirty="0"/>
           </a:p>
@@ -17155,20 +17244,1200 @@
         </p:nvSpPr>
         <p:spPr>
           <a:xfrm>
-            <a:off x="1069848" y="4343400"/>
-            <a:ext cx="7918704" cy="3886200"/>
+            <a:off x="1353312" y="4846320"/>
+            <a:ext cx="12460986" cy="0"/>
+          </a:xfrm>
+          <a:prstGeom prst="line">
+            <a:avLst/>
+          </a:prstGeom>
+          <a:noFill/>
+          <a:ln w="38100">
+            <a:solidFill>
+              <a:srgbClr val="DADBD6"/>
+            </a:solidFill>
+            <a:prstDash val="solid"/>
+          </a:ln>
+        </p:spPr>
+      </p:sp>
+      <p:sp>
+        <p:nvSpPr>
+          <p:cNvPr id="8" name="Shape 5"/>
+          <p:cNvSpPr/>
+          <p:nvPr/>
+        </p:nvSpPr>
+        <p:spPr>
+          <a:xfrm>
+            <a:off x="1353312" y="4846320"/>
+            <a:ext cx="1871091" cy="0"/>
+          </a:xfrm>
+          <a:prstGeom prst="line">
+            <a:avLst/>
+          </a:prstGeom>
+          <a:noFill/>
+          <a:ln w="38100">
+            <a:solidFill>
+              <a:srgbClr val="171717"/>
+            </a:solidFill>
+            <a:prstDash val="solid"/>
+          </a:ln>
+        </p:spPr>
+      </p:sp>
+      <p:sp>
+        <p:nvSpPr>
+          <p:cNvPr id="9" name="Shape 6"/>
+          <p:cNvSpPr/>
+          <p:nvPr/>
+        </p:nvSpPr>
+        <p:spPr>
+          <a:xfrm>
+            <a:off x="914400" y="4407408"/>
+            <a:ext cx="877824" cy="877824"/>
+          </a:xfrm>
+          <a:prstGeom prst="ellipse">
+            <a:avLst/>
+          </a:prstGeom>
+          <a:solidFill>
+            <a:srgbClr val="FBFBFB"/>
+          </a:solidFill>
+          <a:ln w="15875">
+            <a:solidFill>
+              <a:srgbClr val="B5B7B3"/>
+            </a:solidFill>
+            <a:prstDash val="solid"/>
+          </a:ln>
+        </p:spPr>
+      </p:sp>
+      <p:sp>
+        <p:nvSpPr>
+          <p:cNvPr id="10" name="Shape 7"/>
+          <p:cNvSpPr/>
+          <p:nvPr/>
+        </p:nvSpPr>
+        <p:spPr>
+          <a:xfrm>
+            <a:off x="1069848" y="4562856"/>
+            <a:ext cx="566928" cy="566928"/>
+          </a:xfrm>
+          <a:prstGeom prst="ellipse">
+            <a:avLst/>
+          </a:prstGeom>
+          <a:solidFill>
+            <a:srgbClr val="171717"/>
+          </a:solidFill>
+          <a:ln w="12700">
+            <a:solidFill>
+              <a:srgbClr val="171717"/>
+            </a:solidFill>
+            <a:prstDash val="solid"/>
+          </a:ln>
+        </p:spPr>
+      </p:sp>
+      <p:sp>
+        <p:nvSpPr>
+          <p:cNvPr id="11" name="Text 8"/>
+          <p:cNvSpPr txBox="1"/>
+          <p:nvPr/>
+        </p:nvSpPr>
+        <p:spPr>
+          <a:xfrm>
+            <a:off x="1069848" y="5349240"/>
+            <a:ext cx="3742182" cy="274320"/>
+          </a:xfrm>
+          <a:prstGeom prst="rect">
+            <a:avLst/>
+          </a:prstGeom>
+          <a:noFill/>
+          <a:ln/>
+        </p:spPr>
+        <p:txBody>
+          <a:bodyPr wrap="square" lIns="0" tIns="0" rIns="0" bIns="0" rtlCol="0" anchor="t"/>
+          <a:lstStyle/>
+          <a:p>
+            <a:pPr indent="0" marL="0">
+              <a:buNone/>
+            </a:pPr>
+            <a:r>
+              <a:rPr lang="en-US" sz="1050" b="1" spc="150" kern="0" dirty="0">
+                <a:solidFill>
+                  <a:srgbClr val="171717"/>
+                </a:solidFill>
+                <a:latin typeface="Poppins" pitchFamily="34" charset="0"/>
+                <a:ea typeface="Poppins" pitchFamily="34" charset="-122"/>
+                <a:cs typeface="Poppins" pitchFamily="34" charset="-120"/>
+              </a:rPr>
+              <a:t>NOW</a:t>
+            </a:r>
+            <a:endParaRPr lang="en-US" sz="1050" dirty="0"/>
+          </a:p>
+        </p:txBody>
+      </p:sp>
+      <p:sp>
+        <p:nvSpPr>
+          <p:cNvPr id="12" name="Text 9"/>
+          <p:cNvSpPr txBox="1"/>
+          <p:nvPr/>
+        </p:nvSpPr>
+        <p:spPr>
+          <a:xfrm>
+            <a:off x="1069848" y="5650992"/>
+            <a:ext cx="3742182" cy="502920"/>
+          </a:xfrm>
+          <a:prstGeom prst="rect">
+            <a:avLst/>
+          </a:prstGeom>
+          <a:noFill/>
+          <a:ln/>
+        </p:spPr>
+        <p:txBody>
+          <a:bodyPr wrap="square" lIns="0" tIns="0" rIns="0" bIns="0" rtlCol="0" anchor="t"/>
+          <a:lstStyle/>
+          <a:p>
+            <a:pPr indent="0" marL="0">
+              <a:buNone/>
+            </a:pPr>
+            <a:r>
+              <a:rPr lang="en-US" sz="2600" b="1" dirty="0">
+                <a:solidFill>
+                  <a:srgbClr val="171717"/>
+                </a:solidFill>
+                <a:latin typeface="Poppins" pitchFamily="34" charset="0"/>
+                <a:ea typeface="Poppins" pitchFamily="34" charset="-122"/>
+                <a:cs typeface="Poppins" pitchFamily="34" charset="-120"/>
+              </a:rPr>
+              <a:t>PLAN AND VALIDATE</a:t>
+            </a:r>
+            <a:endParaRPr lang="en-US" sz="2600" dirty="0"/>
+          </a:p>
+        </p:txBody>
+      </p:sp>
+      <p:sp>
+        <p:nvSpPr>
+          <p:cNvPr id="13" name="Text 10"/>
+          <p:cNvSpPr txBox="1"/>
+          <p:nvPr/>
+        </p:nvSpPr>
+        <p:spPr>
+          <a:xfrm>
+            <a:off x="1069848" y="6217920"/>
+            <a:ext cx="3742182" cy="1371600"/>
+          </a:xfrm>
+          <a:prstGeom prst="rect">
+            <a:avLst/>
+          </a:prstGeom>
+          <a:noFill/>
+          <a:ln/>
+        </p:spPr>
+        <p:txBody>
+          <a:bodyPr wrap="square" lIns="0" tIns="0" rIns="0" bIns="0" rtlCol="0" anchor="t"/>
+          <a:lstStyle/>
+          <a:p>
+            <a:pPr indent="0" marL="0">
+              <a:lnSpc>
+                <a:spcPct val="108000"/>
+              </a:lnSpc>
+              <a:buNone/>
+            </a:pPr>
+            <a:r>
+              <a:rPr lang="en-US" sz="1500" b="1" dirty="0">
+                <a:solidFill>
+                  <a:srgbClr val="3B3E3C"/>
+                </a:solidFill>
+                <a:latin typeface="Poppins" pitchFamily="34" charset="0"/>
+                <a:ea typeface="Poppins" pitchFamily="34" charset="-122"/>
+                <a:cs typeface="Poppins" pitchFamily="34" charset="-120"/>
+              </a:rPr>
+              <a:t>Planning the product.</a:t>
+            </a:r>
+            <a:endParaRPr lang="en-US" sz="1500" dirty="0"/>
+          </a:p>
+          <a:p>
+            <a:pPr indent="0" marL="0">
+              <a:lnSpc>
+                <a:spcPct val="108000"/>
+              </a:lnSpc>
+              <a:buNone/>
+            </a:pPr>
+            <a:r>
+              <a:rPr lang="en-US" sz="1500" dirty="0">
+                <a:solidFill>
+                  <a:srgbClr val="3B3E3C"/>
+                </a:solidFill>
+                <a:latin typeface="Poppins" pitchFamily="34" charset="0"/>
+                <a:ea typeface="Poppins" pitchFamily="34" charset="-122"/>
+                <a:cs typeface="Poppins" pitchFamily="34" charset="-120"/>
+              </a:rPr>
+              <a:t>Validating the legal model country by country.</a:t>
+            </a:r>
+            <a:endParaRPr lang="en-US" sz="1500" dirty="0"/>
+          </a:p>
+        </p:txBody>
+      </p:sp>
+      <p:sp>
+        <p:nvSpPr>
+          <p:cNvPr id="14" name="Shape 11"/>
+          <p:cNvSpPr/>
+          <p:nvPr/>
+        </p:nvSpPr>
+        <p:spPr>
+          <a:xfrm>
+            <a:off x="5223510" y="4562856"/>
+            <a:ext cx="566928" cy="566928"/>
+          </a:xfrm>
+          <a:prstGeom prst="ellipse">
+            <a:avLst/>
+          </a:prstGeom>
+          <a:solidFill>
+            <a:srgbClr val="497078"/>
+          </a:solidFill>
+          <a:ln w="12700">
+            <a:solidFill>
+              <a:srgbClr val="497078"/>
+            </a:solidFill>
+            <a:prstDash val="solid"/>
+          </a:ln>
+        </p:spPr>
+      </p:sp>
+      <p:sp>
+        <p:nvSpPr>
+          <p:cNvPr id="15" name="Shape 12"/>
+          <p:cNvSpPr/>
+          <p:nvPr/>
+        </p:nvSpPr>
+        <p:spPr>
+          <a:xfrm>
+            <a:off x="5424678" y="4764024"/>
+            <a:ext cx="164592" cy="164592"/>
+          </a:xfrm>
+          <a:prstGeom prst="ellipse">
+            <a:avLst/>
+          </a:prstGeom>
+          <a:solidFill>
+            <a:srgbClr val="FFFFFF"/>
+          </a:solidFill>
+          <a:ln w="12700">
+            <a:solidFill>
+              <a:srgbClr val="FFFFFF"/>
+            </a:solidFill>
+            <a:prstDash val="solid"/>
+          </a:ln>
+        </p:spPr>
+      </p:sp>
+      <p:sp>
+        <p:nvSpPr>
+          <p:cNvPr id="16" name="Text 13"/>
+          <p:cNvSpPr txBox="1"/>
+          <p:nvPr/>
+        </p:nvSpPr>
+        <p:spPr>
+          <a:xfrm>
+            <a:off x="5223510" y="5349240"/>
+            <a:ext cx="3742182" cy="274320"/>
+          </a:xfrm>
+          <a:prstGeom prst="rect">
+            <a:avLst/>
+          </a:prstGeom>
+          <a:noFill/>
+          <a:ln/>
+        </p:spPr>
+        <p:txBody>
+          <a:bodyPr wrap="square" lIns="0" tIns="0" rIns="0" bIns="0" rtlCol="0" anchor="t"/>
+          <a:lstStyle/>
+          <a:p>
+            <a:pPr indent="0" marL="0">
+              <a:buNone/>
+            </a:pPr>
+            <a:r>
+              <a:rPr lang="en-US" sz="1050" b="1" spc="150" kern="0" dirty="0">
+                <a:solidFill>
+                  <a:srgbClr val="315D66"/>
+                </a:solidFill>
+                <a:latin typeface="Poppins" pitchFamily="34" charset="0"/>
+                <a:ea typeface="Poppins" pitchFamily="34" charset="-122"/>
+                <a:cs typeface="Poppins" pitchFamily="34" charset="-120"/>
+              </a:rPr>
+              <a:t>AI ENTREPRENEURS LAB</a:t>
+            </a:r>
+            <a:endParaRPr lang="en-US" sz="1050" dirty="0"/>
+          </a:p>
+        </p:txBody>
+      </p:sp>
+      <p:sp>
+        <p:nvSpPr>
+          <p:cNvPr id="17" name="Text 14"/>
+          <p:cNvSpPr txBox="1"/>
+          <p:nvPr/>
+        </p:nvSpPr>
+        <p:spPr>
+          <a:xfrm>
+            <a:off x="5223510" y="5650992"/>
+            <a:ext cx="3742182" cy="502920"/>
+          </a:xfrm>
+          <a:prstGeom prst="rect">
+            <a:avLst/>
+          </a:prstGeom>
+          <a:noFill/>
+          <a:ln/>
+        </p:spPr>
+        <p:txBody>
+          <a:bodyPr wrap="square" lIns="0" tIns="0" rIns="0" bIns="0" rtlCol="0" anchor="t"/>
+          <a:lstStyle/>
+          <a:p>
+            <a:pPr indent="0" marL="0">
+              <a:buNone/>
+            </a:pPr>
+            <a:r>
+              <a:rPr lang="en-US" sz="2600" b="1" dirty="0">
+                <a:solidFill>
+                  <a:srgbClr val="171717"/>
+                </a:solidFill>
+                <a:latin typeface="Poppins" pitchFamily="34" charset="0"/>
+                <a:ea typeface="Poppins" pitchFamily="34" charset="-122"/>
+                <a:cs typeface="Poppins" pitchFamily="34" charset="-120"/>
+              </a:rPr>
+              <a:t>BUILD</a:t>
+            </a:r>
+            <a:endParaRPr lang="en-US" sz="2600" dirty="0"/>
+          </a:p>
+        </p:txBody>
+      </p:sp>
+      <p:sp>
+        <p:nvSpPr>
+          <p:cNvPr id="18" name="Text 15"/>
+          <p:cNvSpPr txBox="1"/>
+          <p:nvPr/>
+        </p:nvSpPr>
+        <p:spPr>
+          <a:xfrm>
+            <a:off x="5223510" y="6217920"/>
+            <a:ext cx="3742182" cy="1371600"/>
+          </a:xfrm>
+          <a:prstGeom prst="rect">
+            <a:avLst/>
+          </a:prstGeom>
+          <a:noFill/>
+          <a:ln/>
+        </p:spPr>
+        <p:txBody>
+          <a:bodyPr wrap="square" lIns="0" tIns="0" rIns="0" bIns="0" rtlCol="0" anchor="t"/>
+          <a:lstStyle/>
+          <a:p>
+            <a:pPr indent="0" marL="0">
+              <a:lnSpc>
+                <a:spcPct val="108000"/>
+              </a:lnSpc>
+              <a:buNone/>
+            </a:pPr>
+            <a:r>
+              <a:rPr lang="en-US" sz="1500" b="1" dirty="0">
+                <a:solidFill>
+                  <a:srgbClr val="3B3E3C"/>
+                </a:solidFill>
+                <a:latin typeface="Poppins" pitchFamily="34" charset="0"/>
+                <a:ea typeface="Poppins" pitchFamily="34" charset="-122"/>
+                <a:cs typeface="Poppins" pitchFamily="34" charset="-120"/>
+              </a:rPr>
+              <a:t>Build the MVP.</a:t>
+            </a:r>
+            <a:endParaRPr lang="en-US" sz="1500" dirty="0"/>
+          </a:p>
+          <a:p>
+            <a:pPr indent="0" marL="0">
+              <a:lnSpc>
+                <a:spcPct val="108000"/>
+              </a:lnSpc>
+              <a:buNone/>
+            </a:pPr>
+            <a:r>
+              <a:rPr lang="en-US" sz="1500" dirty="0">
+                <a:solidFill>
+                  <a:srgbClr val="3B3E3C"/>
+                </a:solidFill>
+                <a:latin typeface="Poppins" pitchFamily="34" charset="0"/>
+                <a:ea typeface="Poppins" pitchFamily="34" charset="-122"/>
+                <a:cs typeface="Poppins" pitchFamily="34" charset="-120"/>
+              </a:rPr>
+              <a:t>Evidence graph, adviser, legal gate.</a:t>
+            </a:r>
+            <a:endParaRPr lang="en-US" sz="1500" dirty="0"/>
+          </a:p>
+        </p:txBody>
+      </p:sp>
+      <p:sp>
+        <p:nvSpPr>
+          <p:cNvPr id="19" name="Shape 16"/>
+          <p:cNvSpPr/>
+          <p:nvPr/>
+        </p:nvSpPr>
+        <p:spPr>
+          <a:xfrm>
+            <a:off x="9377172" y="4562856"/>
+            <a:ext cx="566928" cy="566928"/>
+          </a:xfrm>
+          <a:prstGeom prst="ellipse">
+            <a:avLst/>
+          </a:prstGeom>
+          <a:solidFill>
+            <a:srgbClr val="FBFBFB"/>
+          </a:solidFill>
+          <a:ln w="22225">
+            <a:solidFill>
+              <a:srgbClr val="B9BBB7"/>
+            </a:solidFill>
+            <a:prstDash val="solid"/>
+          </a:ln>
+        </p:spPr>
+      </p:sp>
+      <p:sp>
+        <p:nvSpPr>
+          <p:cNvPr id="20" name="Text 17"/>
+          <p:cNvSpPr txBox="1"/>
+          <p:nvPr/>
+        </p:nvSpPr>
+        <p:spPr>
+          <a:xfrm>
+            <a:off x="9377172" y="5349240"/>
+            <a:ext cx="3742182" cy="274320"/>
+          </a:xfrm>
+          <a:prstGeom prst="rect">
+            <a:avLst/>
+          </a:prstGeom>
+          <a:noFill/>
+          <a:ln/>
+        </p:spPr>
+        <p:txBody>
+          <a:bodyPr wrap="square" lIns="0" tIns="0" rIns="0" bIns="0" rtlCol="0" anchor="t"/>
+          <a:lstStyle/>
+          <a:p>
+            <a:pPr indent="0" marL="0">
+              <a:buNone/>
+            </a:pPr>
+            <a:r>
+              <a:rPr lang="en-US" sz="1050" b="1" spc="150" kern="0" dirty="0">
+                <a:solidFill>
+                  <a:srgbClr val="687075"/>
+                </a:solidFill>
+                <a:latin typeface="Poppins" pitchFamily="34" charset="0"/>
+                <a:ea typeface="Poppins" pitchFamily="34" charset="-122"/>
+                <a:cs typeface="Poppins" pitchFamily="34" charset="-120"/>
+              </a:rPr>
+              <a:t>THEN</a:t>
+            </a:r>
+            <a:endParaRPr lang="en-US" sz="1050" dirty="0"/>
+          </a:p>
+        </p:txBody>
+      </p:sp>
+      <p:sp>
+        <p:nvSpPr>
+          <p:cNvPr id="21" name="Text 18"/>
+          <p:cNvSpPr txBox="1"/>
+          <p:nvPr/>
+        </p:nvSpPr>
+        <p:spPr>
+          <a:xfrm>
+            <a:off x="9377172" y="5650992"/>
+            <a:ext cx="3742182" cy="502920"/>
+          </a:xfrm>
+          <a:prstGeom prst="rect">
+            <a:avLst/>
+          </a:prstGeom>
+          <a:noFill/>
+          <a:ln/>
+        </p:spPr>
+        <p:txBody>
+          <a:bodyPr wrap="square" lIns="0" tIns="0" rIns="0" bIns="0" rtlCol="0" anchor="t"/>
+          <a:lstStyle/>
+          <a:p>
+            <a:pPr indent="0" marL="0">
+              <a:buNone/>
+            </a:pPr>
+            <a:r>
+              <a:rPr lang="en-US" sz="2600" b="1" dirty="0">
+                <a:solidFill>
+                  <a:srgbClr val="4A4D4A"/>
+                </a:solidFill>
+                <a:latin typeface="Poppins" pitchFamily="34" charset="0"/>
+                <a:ea typeface="Poppins" pitchFamily="34" charset="-122"/>
+                <a:cs typeface="Poppins" pitchFamily="34" charset="-120"/>
+              </a:rPr>
+              <a:t>LAUNCH</a:t>
+            </a:r>
+            <a:endParaRPr lang="en-US" sz="2600" dirty="0"/>
+          </a:p>
+        </p:txBody>
+      </p:sp>
+      <p:sp>
+        <p:nvSpPr>
+          <p:cNvPr id="22" name="Text 19"/>
+          <p:cNvSpPr txBox="1"/>
+          <p:nvPr/>
+        </p:nvSpPr>
+        <p:spPr>
+          <a:xfrm>
+            <a:off x="9377172" y="6217920"/>
+            <a:ext cx="3742182" cy="1371600"/>
+          </a:xfrm>
+          <a:prstGeom prst="rect">
+            <a:avLst/>
+          </a:prstGeom>
+          <a:noFill/>
+          <a:ln/>
+        </p:spPr>
+        <p:txBody>
+          <a:bodyPr wrap="square" lIns="0" tIns="0" rIns="0" bIns="0" rtlCol="0" anchor="t"/>
+          <a:lstStyle/>
+          <a:p>
+            <a:pPr indent="0" marL="0">
+              <a:lnSpc>
+                <a:spcPct val="108000"/>
+              </a:lnSpc>
+              <a:buNone/>
+            </a:pPr>
+            <a:r>
+              <a:rPr lang="en-US" sz="1500" b="1" dirty="0">
+                <a:solidFill>
+                  <a:srgbClr val="687075"/>
+                </a:solidFill>
+                <a:latin typeface="Poppins" pitchFamily="34" charset="0"/>
+                <a:ea typeface="Poppins" pitchFamily="34" charset="-122"/>
+                <a:cs typeface="Poppins" pitchFamily="34" charset="-120"/>
+              </a:rPr>
+              <a:t>NIS2 readiness in the Netherlands.</a:t>
+            </a:r>
+            <a:endParaRPr lang="en-US" sz="1500" dirty="0"/>
+          </a:p>
+          <a:p>
+            <a:pPr indent="0" marL="0">
+              <a:lnSpc>
+                <a:spcPct val="108000"/>
+              </a:lnSpc>
+              <a:buNone/>
+            </a:pPr>
+            <a:r>
+              <a:rPr lang="en-US" sz="1500" dirty="0">
+                <a:solidFill>
+                  <a:srgbClr val="687075"/>
+                </a:solidFill>
+                <a:latin typeface="Poppins" pitchFamily="34" charset="0"/>
+                <a:ea typeface="Poppins" pitchFamily="34" charset="-122"/>
+                <a:cs typeface="Poppins" pitchFamily="34" charset="-120"/>
+              </a:rPr>
+              <a:t>Win customers. Sign law firm partners.</a:t>
+            </a:r>
+            <a:endParaRPr lang="en-US" sz="1500" dirty="0"/>
+          </a:p>
+        </p:txBody>
+      </p:sp>
+      <p:sp>
+        <p:nvSpPr>
+          <p:cNvPr id="23" name="Shape 20"/>
+          <p:cNvSpPr/>
+          <p:nvPr/>
+        </p:nvSpPr>
+        <p:spPr>
+          <a:xfrm>
+            <a:off x="13530834" y="4562856"/>
+            <a:ext cx="566928" cy="566928"/>
+          </a:xfrm>
+          <a:prstGeom prst="ellipse">
+            <a:avLst/>
+          </a:prstGeom>
+          <a:solidFill>
+            <a:srgbClr val="FBFBFB"/>
+          </a:solidFill>
+          <a:ln w="22225">
+            <a:solidFill>
+              <a:srgbClr val="B9BBB7"/>
+            </a:solidFill>
+            <a:prstDash val="solid"/>
+          </a:ln>
+        </p:spPr>
+      </p:sp>
+      <p:sp>
+        <p:nvSpPr>
+          <p:cNvPr id="24" name="Text 21"/>
+          <p:cNvSpPr txBox="1"/>
+          <p:nvPr/>
+        </p:nvSpPr>
+        <p:spPr>
+          <a:xfrm>
+            <a:off x="13530834" y="5349240"/>
+            <a:ext cx="3742182" cy="274320"/>
+          </a:xfrm>
+          <a:prstGeom prst="rect">
+            <a:avLst/>
+          </a:prstGeom>
+          <a:noFill/>
+          <a:ln/>
+        </p:spPr>
+        <p:txBody>
+          <a:bodyPr wrap="square" lIns="0" tIns="0" rIns="0" bIns="0" rtlCol="0" anchor="t"/>
+          <a:lstStyle/>
+          <a:p>
+            <a:pPr indent="0" marL="0">
+              <a:buNone/>
+            </a:pPr>
+            <a:r>
+              <a:rPr lang="en-US" sz="1050" b="1" spc="150" kern="0" dirty="0">
+                <a:solidFill>
+                  <a:srgbClr val="687075"/>
+                </a:solidFill>
+                <a:latin typeface="Poppins" pitchFamily="34" charset="0"/>
+                <a:ea typeface="Poppins" pitchFamily="34" charset="-122"/>
+                <a:cs typeface="Poppins" pitchFamily="34" charset="-120"/>
+              </a:rPr>
+              <a:t>THEN</a:t>
+            </a:r>
+            <a:endParaRPr lang="en-US" sz="1050" dirty="0"/>
+          </a:p>
+        </p:txBody>
+      </p:sp>
+      <p:sp>
+        <p:nvSpPr>
+          <p:cNvPr id="25" name="Text 22"/>
+          <p:cNvSpPr txBox="1"/>
+          <p:nvPr/>
+        </p:nvSpPr>
+        <p:spPr>
+          <a:xfrm>
+            <a:off x="13530834" y="5650992"/>
+            <a:ext cx="3742182" cy="502920"/>
+          </a:xfrm>
+          <a:prstGeom prst="rect">
+            <a:avLst/>
+          </a:prstGeom>
+          <a:noFill/>
+          <a:ln/>
+        </p:spPr>
+        <p:txBody>
+          <a:bodyPr wrap="square" lIns="0" tIns="0" rIns="0" bIns="0" rtlCol="0" anchor="t"/>
+          <a:lstStyle/>
+          <a:p>
+            <a:pPr indent="0" marL="0">
+              <a:buNone/>
+            </a:pPr>
+            <a:r>
+              <a:rPr lang="en-US" sz="2600" b="1" dirty="0">
+                <a:solidFill>
+                  <a:srgbClr val="4A4D4A"/>
+                </a:solidFill>
+                <a:latin typeface="Poppins" pitchFamily="34" charset="0"/>
+                <a:ea typeface="Poppins" pitchFamily="34" charset="-122"/>
+                <a:cs typeface="Poppins" pitchFamily="34" charset="-120"/>
+              </a:rPr>
+              <a:t>GROW</a:t>
+            </a:r>
+            <a:endParaRPr lang="en-US" sz="2600" dirty="0"/>
+          </a:p>
+        </p:txBody>
+      </p:sp>
+      <p:sp>
+        <p:nvSpPr>
+          <p:cNvPr id="26" name="Text 23"/>
+          <p:cNvSpPr txBox="1"/>
+          <p:nvPr/>
+        </p:nvSpPr>
+        <p:spPr>
+          <a:xfrm>
+            <a:off x="13530834" y="6217920"/>
+            <a:ext cx="3742182" cy="1371600"/>
+          </a:xfrm>
+          <a:prstGeom prst="rect">
+            <a:avLst/>
+          </a:prstGeom>
+          <a:noFill/>
+          <a:ln/>
+        </p:spPr>
+        <p:txBody>
+          <a:bodyPr wrap="square" lIns="0" tIns="0" rIns="0" bIns="0" rtlCol="0" anchor="t"/>
+          <a:lstStyle/>
+          <a:p>
+            <a:pPr indent="0" marL="0">
+              <a:lnSpc>
+                <a:spcPct val="108000"/>
+              </a:lnSpc>
+              <a:buNone/>
+            </a:pPr>
+            <a:r>
+              <a:rPr lang="en-US" sz="1500" b="1" dirty="0">
+                <a:solidFill>
+                  <a:srgbClr val="687075"/>
+                </a:solidFill>
+                <a:latin typeface="Poppins" pitchFamily="34" charset="0"/>
+                <a:ea typeface="Poppins" pitchFamily="34" charset="-122"/>
+                <a:cs typeface="Poppins" pitchFamily="34" charset="-120"/>
+              </a:rPr>
+              <a:t>Sweden next.</a:t>
+            </a:r>
+            <a:endParaRPr lang="en-US" sz="1500" dirty="0"/>
+          </a:p>
+          <a:p>
+            <a:pPr indent="0" marL="0">
+              <a:lnSpc>
+                <a:spcPct val="108000"/>
+              </a:lnSpc>
+              <a:buNone/>
+            </a:pPr>
+            <a:r>
+              <a:rPr lang="en-US" sz="1500" dirty="0">
+                <a:solidFill>
+                  <a:srgbClr val="687075"/>
+                </a:solidFill>
+                <a:latin typeface="Poppins" pitchFamily="34" charset="0"/>
+                <a:ea typeface="Poppins" pitchFamily="34" charset="-122"/>
+                <a:cs typeface="Poppins" pitchFamily="34" charset="-120"/>
+              </a:rPr>
+              <a:t>Germany as a country pack. Every further regulation.</a:t>
+            </a:r>
+            <a:endParaRPr lang="en-US" sz="1500" dirty="0"/>
+          </a:p>
+        </p:txBody>
+      </p:sp>
+      <p:sp>
+        <p:nvSpPr>
+          <p:cNvPr id="27" name="Shape 24"/>
+          <p:cNvSpPr/>
+          <p:nvPr/>
+        </p:nvSpPr>
+        <p:spPr>
+          <a:xfrm>
+            <a:off x="1069848" y="7955280"/>
+            <a:ext cx="16203168" cy="960120"/>
           </a:xfrm>
           <a:prstGeom prst="roundRect">
             <a:avLst>
-              <a:gd name="adj" fmla="val 4706"/>
+              <a:gd name="adj" fmla="val 15238"/>
             </a:avLst>
           </a:prstGeom>
           <a:solidFill>
-            <a:srgbClr val="FFFFFF"/>
+            <a:srgbClr val="E8F2F2"/>
           </a:solidFill>
           <a:ln w="9525">
             <a:solidFill>
+              <a:srgbClr val="E8F2F2"/>
+            </a:solidFill>
+            <a:prstDash val="solid"/>
+          </a:ln>
+        </p:spPr>
+      </p:sp>
+      <p:sp>
+        <p:nvSpPr>
+          <p:cNvPr id="28" name="Shape 25"/>
+          <p:cNvSpPr/>
+          <p:nvPr/>
+        </p:nvSpPr>
+        <p:spPr>
+          <a:xfrm rot="16200000">
+            <a:off x="1732788" y="7292340"/>
+            <a:ext cx="960120" cy="2286000"/>
+          </a:xfrm>
+          <a:prstGeom prst="round2SameRect">
+            <a:avLst>
+              <a:gd name="adj" fmla="val 15238"/>
+            </a:avLst>
+          </a:prstGeom>
+          <a:solidFill>
+            <a:srgbClr val="171717"/>
+          </a:solidFill>
+          <a:ln w="12700">
+            <a:solidFill>
+              <a:srgbClr val="171717"/>
+            </a:solidFill>
+            <a:prstDash val="solid"/>
+          </a:ln>
+        </p:spPr>
+      </p:sp>
+      <p:sp>
+        <p:nvSpPr>
+          <p:cNvPr id="29" name="Text 26"/>
+          <p:cNvSpPr txBox="1"/>
+          <p:nvPr/>
+        </p:nvSpPr>
+        <p:spPr>
+          <a:xfrm>
+            <a:off x="1069848" y="7955280"/>
+            <a:ext cx="2286000" cy="960120"/>
+          </a:xfrm>
+          <a:prstGeom prst="rect">
+            <a:avLst/>
+          </a:prstGeom>
+          <a:noFill/>
+          <a:ln/>
+        </p:spPr>
+        <p:txBody>
+          <a:bodyPr wrap="square" lIns="0" tIns="0" rIns="0" bIns="0" rtlCol="0" anchor="ctr"/>
+          <a:lstStyle/>
+          <a:p>
+            <a:pPr algn="ctr" indent="0" marL="0">
+              <a:buNone/>
+            </a:pPr>
+            <a:r>
+              <a:rPr lang="en-US" sz="1100" b="1" spc="200" kern="0" dirty="0">
+                <a:solidFill>
+                  <a:srgbClr val="FFFFFF"/>
+                </a:solidFill>
+                <a:latin typeface="Poppins" pitchFamily="34" charset="0"/>
+                <a:ea typeface="Poppins" pitchFamily="34" charset="-122"/>
+                <a:cs typeface="Poppins" pitchFamily="34" charset="-120"/>
+              </a:rPr>
+              <a:t>OUR MISSION</a:t>
+            </a:r>
+            <a:endParaRPr lang="en-US" sz="1100" dirty="0"/>
+          </a:p>
+        </p:txBody>
+      </p:sp>
+      <p:sp>
+        <p:nvSpPr>
+          <p:cNvPr id="30" name="Text 27"/>
+          <p:cNvSpPr txBox="1"/>
+          <p:nvPr/>
+        </p:nvSpPr>
+        <p:spPr>
+          <a:xfrm>
+            <a:off x="3767328" y="7955280"/>
+            <a:ext cx="13185648" cy="960120"/>
+          </a:xfrm>
+          <a:prstGeom prst="rect">
+            <a:avLst/>
+          </a:prstGeom>
+          <a:noFill/>
+          <a:ln/>
+        </p:spPr>
+        <p:txBody>
+          <a:bodyPr wrap="square" lIns="0" tIns="0" rIns="0" bIns="0" rtlCol="0" anchor="ctr"/>
+          <a:lstStyle/>
+          <a:p>
+            <a:pPr indent="0" marL="0">
+              <a:buNone/>
+            </a:pPr>
+            <a:r>
+              <a:rPr lang="en-US" sz="2200" b="1" spc="-50" kern="0" dirty="0">
+                <a:solidFill>
+                  <a:srgbClr val="171717"/>
+                </a:solidFill>
+                <a:latin typeface="Poppins" pitchFamily="34" charset="0"/>
+                <a:ea typeface="Poppins" pitchFamily="34" charset="-122"/>
+                <a:cs typeface="Poppins" pitchFamily="34" charset="-120"/>
+              </a:rPr>
+              <a:t>Companies spend less on regulation and more on what makes them </a:t>
+            </a:r>
+            <a:pPr indent="0" marL="0">
+              <a:buNone/>
+            </a:pPr>
+            <a:r>
+              <a:rPr lang="en-US" sz="2200" b="1" spc="-50" kern="0" dirty="0">
+                <a:solidFill>
+                  <a:srgbClr val="315D66"/>
+                </a:solidFill>
+                <a:latin typeface="Poppins" pitchFamily="34" charset="0"/>
+                <a:ea typeface="Poppins" pitchFamily="34" charset="-122"/>
+                <a:cs typeface="Poppins" pitchFamily="34" charset="-120"/>
+              </a:rPr>
+              <a:t>competitive.</a:t>
+            </a:r>
+            <a:endParaRPr lang="en-US" sz="2200" dirty="0"/>
+          </a:p>
+        </p:txBody>
+      </p:sp>
+    </p:spTree>
+  </p:cSld>
+  <p:clrMapOvr>
+    <a:masterClrMapping/>
+  </p:clrMapOvr>
+</p:sld>
+</file>
+
+<file path=ppt/slides/slide6.xml><?xml version="1.0" encoding="utf-8"?>
+<p:sld xmlns:a="http://schemas.openxmlformats.org/drawingml/2006/main" xmlns:r="http://schemas.openxmlformats.org/officeDocument/2006/relationships" xmlns:p="http://schemas.openxmlformats.org/presentationml/2006/main">
+  <p:cSld name="Slide 6">
+    <p:spTree>
+      <p:nvGrpSpPr>
+        <p:cNvPr id="1" name=""/>
+        <p:cNvGrpSpPr/>
+        <p:nvPr/>
+      </p:nvGrpSpPr>
+      <p:grpSpPr>
+        <a:xfrm>
+          <a:off x="0" y="0"/>
+          <a:ext cx="0" cy="0"/>
+          <a:chOff x="0" y="0"/>
+          <a:chExt cx="0" cy="0"/>
+        </a:xfrm>
+      </p:grpSpPr>
+      <p:sp>
+        <p:nvSpPr>
+          <p:cNvPr id="2" name="Text 0"/>
+          <p:cNvSpPr txBox="1"/>
+          <p:nvPr/>
+        </p:nvSpPr>
+        <p:spPr>
+          <a:xfrm>
+            <a:off x="1069848" y="1993392"/>
+            <a:ext cx="9144000" cy="347472"/>
+          </a:xfrm>
+          <a:prstGeom prst="rect">
+            <a:avLst/>
+          </a:prstGeom>
+          <a:noFill/>
+          <a:ln/>
+        </p:spPr>
+        <p:txBody>
+          <a:bodyPr wrap="square" lIns="0" tIns="0" rIns="0" bIns="0" rtlCol="0" anchor="t"/>
+          <a:lstStyle/>
+          <a:p>
+            <a:pPr indent="0" marL="0">
+              <a:buNone/>
+            </a:pPr>
+            <a:r>
+              <a:rPr lang="en-US" sz="1700" b="1" spc="100" kern="0" dirty="0">
+                <a:solidFill>
+                  <a:srgbClr val="497078"/>
+                </a:solidFill>
+                <a:latin typeface="Poppins" pitchFamily="34" charset="0"/>
+                <a:ea typeface="Poppins" pitchFamily="34" charset="-122"/>
+                <a:cs typeface="Poppins" pitchFamily="34" charset="-120"/>
+              </a:rPr>
+              <a:t>MARKET PAIN POINTS</a:t>
+            </a:r>
+            <a:endParaRPr lang="en-US" sz="1700" dirty="0"/>
+          </a:p>
+        </p:txBody>
+      </p:sp>
+      <p:sp>
+        <p:nvSpPr>
+          <p:cNvPr id="3" name="Text 1"/>
+          <p:cNvSpPr txBox="1"/>
+          <p:nvPr/>
+        </p:nvSpPr>
+        <p:spPr>
+          <a:xfrm>
+            <a:off x="1042416" y="2496312"/>
+            <a:ext cx="16203168" cy="868680"/>
+          </a:xfrm>
+          <a:prstGeom prst="rect">
+            <a:avLst/>
+          </a:prstGeom>
+          <a:noFill/>
+          <a:ln/>
+        </p:spPr>
+        <p:txBody>
+          <a:bodyPr wrap="square" lIns="0" tIns="0" rIns="0" bIns="0" rtlCol="0" anchor="t"/>
+          <a:lstStyle/>
+          <a:p>
+            <a:pPr indent="0" marL="0">
+              <a:buNone/>
+            </a:pPr>
+            <a:r>
+              <a:rPr lang="en-US" sz="5300" b="1" spc="-100" kern="0" dirty="0">
+                <a:solidFill>
+                  <a:srgbClr val="171717"/>
+                </a:solidFill>
+                <a:latin typeface="Poppins" pitchFamily="34" charset="0"/>
+                <a:ea typeface="Poppins" pitchFamily="34" charset="-122"/>
+                <a:cs typeface="Poppins" pitchFamily="34" charset="-120"/>
+              </a:rPr>
+              <a:t>COMPLIANCE IS STILL </a:t>
+            </a:r>
+            <a:pPr indent="0" marL="0">
+              <a:buNone/>
+            </a:pPr>
+            <a:r>
+              <a:rPr lang="en-US" sz="5300" b="1" spc="-100" kern="0" dirty="0">
+                <a:solidFill>
+                  <a:srgbClr val="A95E53"/>
+                </a:solidFill>
+                <a:latin typeface="Poppins" pitchFamily="34" charset="0"/>
+                <a:ea typeface="Poppins" pitchFamily="34" charset="-122"/>
+                <a:cs typeface="Poppins" pitchFamily="34" charset="-120"/>
+              </a:rPr>
+              <a:t>GUESSWORK.</a:t>
+            </a:r>
+            <a:endParaRPr lang="en-US" sz="5300" dirty="0"/>
+          </a:p>
+        </p:txBody>
+      </p:sp>
+      <p:sp>
+        <p:nvSpPr>
+          <p:cNvPr id="4" name="Text 2"/>
+          <p:cNvSpPr txBox="1"/>
+          <p:nvPr/>
+        </p:nvSpPr>
+        <p:spPr>
+          <a:xfrm>
+            <a:off x="1069848" y="3557016"/>
+            <a:ext cx="16203168" cy="420624"/>
+          </a:xfrm>
+          <a:prstGeom prst="rect">
+            <a:avLst/>
+          </a:prstGeom>
+          <a:noFill/>
+          <a:ln/>
+        </p:spPr>
+        <p:txBody>
+          <a:bodyPr wrap="square" lIns="0" tIns="0" rIns="0" bIns="0" rtlCol="0" anchor="t"/>
+          <a:lstStyle/>
+          <a:p>
+            <a:pPr indent="0" marL="0">
+              <a:buNone/>
+            </a:pPr>
+            <a:r>
+              <a:rPr lang="en-US" sz="1950" dirty="0">
+                <a:solidFill>
+                  <a:srgbClr val="687075"/>
+                </a:solidFill>
+                <a:latin typeface="Poppins" pitchFamily="34" charset="0"/>
+                <a:ea typeface="Poppins" pitchFamily="34" charset="-122"/>
+                <a:cs typeface="Poppins" pitchFamily="34" charset="-120"/>
+              </a:rPr>
+              <a:t>Companies pay to reconstruct facts that already exist in their systems.</a:t>
+            </a:r>
+            <a:endParaRPr lang="en-US" sz="1950" dirty="0"/>
+          </a:p>
+        </p:txBody>
+      </p:sp>
+      <p:sp>
+        <p:nvSpPr>
+          <p:cNvPr id="5" name="Shape 3"/>
+          <p:cNvSpPr/>
+          <p:nvPr/>
+        </p:nvSpPr>
+        <p:spPr>
+          <a:xfrm>
+            <a:off x="1069848" y="4050792"/>
+            <a:ext cx="16203168" cy="0"/>
+          </a:xfrm>
+          <a:prstGeom prst="line">
+            <a:avLst/>
+          </a:prstGeom>
+          <a:noFill/>
+          <a:ln w="9525">
+            <a:solidFill>
               <a:srgbClr val="DADBD6"/>
+            </a:solidFill>
+            <a:prstDash val="solid"/>
+          </a:ln>
+        </p:spPr>
+      </p:sp>
+      <p:sp>
+        <p:nvSpPr>
+          <p:cNvPr id="7" name="Text 4"/>
+          <p:cNvSpPr txBox="1"/>
+          <p:nvPr/>
+        </p:nvSpPr>
+        <p:spPr>
+          <a:xfrm>
+            <a:off x="1069848" y="4572000"/>
+            <a:ext cx="3657600" cy="411480"/>
+          </a:xfrm>
+          <a:prstGeom prst="rect">
+            <a:avLst/>
+          </a:prstGeom>
+          <a:noFill/>
+          <a:ln/>
+        </p:spPr>
+        <p:txBody>
+          <a:bodyPr wrap="square" lIns="0" tIns="0" rIns="0" bIns="0" rtlCol="0" anchor="t"/>
+          <a:lstStyle/>
+          <a:p>
+            <a:pPr indent="0" marL="0">
+              <a:buNone/>
+            </a:pPr>
+            <a:r>
+              <a:rPr lang="en-US" sz="1900" b="1" dirty="0">
+                <a:solidFill>
+                  <a:srgbClr val="171717"/>
+                </a:solidFill>
+                <a:latin typeface="Poppins" pitchFamily="34" charset="0"/>
+                <a:ea typeface="Poppins" pitchFamily="34" charset="-122"/>
+                <a:cs typeface="Poppins" pitchFamily="34" charset="-120"/>
+              </a:rPr>
+              <a:t>TODAY</a:t>
+            </a:r>
+            <a:endParaRPr lang="en-US" sz="1900" dirty="0"/>
+          </a:p>
+        </p:txBody>
+      </p:sp>
+      <p:sp>
+        <p:nvSpPr>
+          <p:cNvPr id="8" name="Text 5"/>
+          <p:cNvSpPr txBox="1"/>
+          <p:nvPr/>
+        </p:nvSpPr>
+        <p:spPr>
+          <a:xfrm>
+            <a:off x="5824728" y="4645152"/>
+            <a:ext cx="3657600" cy="320040"/>
+          </a:xfrm>
+          <a:prstGeom prst="rect">
+            <a:avLst/>
+          </a:prstGeom>
+          <a:noFill/>
+          <a:ln/>
+        </p:spPr>
+        <p:txBody>
+          <a:bodyPr wrap="square" lIns="0" tIns="0" rIns="0" bIns="0" rtlCol="0" anchor="t"/>
+          <a:lstStyle/>
+          <a:p>
+            <a:pPr algn="r" indent="0" marL="0">
+              <a:buNone/>
+            </a:pPr>
+            <a:r>
+              <a:rPr lang="en-US" sz="1050" b="1" spc="150" kern="0" dirty="0">
+                <a:solidFill>
+                  <a:srgbClr val="A95E53"/>
+                </a:solidFill>
+                <a:latin typeface="Poppins" pitchFamily="34" charset="0"/>
+                <a:ea typeface="Poppins" pitchFamily="34" charset="-122"/>
+                <a:cs typeface="Poppins" pitchFamily="34" charset="-120"/>
+              </a:rPr>
+              <a:t>OUTSIDE-IN</a:t>
+            </a:r>
+            <a:endParaRPr lang="en-US" sz="1050" dirty="0"/>
+          </a:p>
+        </p:txBody>
+      </p:sp>
+      <p:sp>
+        <p:nvSpPr>
+          <p:cNvPr id="9" name="Shape 6"/>
+          <p:cNvSpPr/>
+          <p:nvPr/>
+        </p:nvSpPr>
+        <p:spPr>
+          <a:xfrm>
+            <a:off x="1069848" y="5074920"/>
+            <a:ext cx="8412480" cy="0"/>
+          </a:xfrm>
+          <a:prstGeom prst="line">
+            <a:avLst/>
+          </a:prstGeom>
+          <a:noFill/>
+          <a:ln w="19050">
+            <a:solidFill>
+              <a:srgbClr val="171717"/>
+            </a:solidFill>
+            <a:prstDash val="solid"/>
+          </a:ln>
+        </p:spPr>
+      </p:sp>
+      <p:sp>
+        <p:nvSpPr>
+          <p:cNvPr id="10" name="Shape 7"/>
+          <p:cNvSpPr/>
+          <p:nvPr/>
+        </p:nvSpPr>
+        <p:spPr>
+          <a:xfrm>
+            <a:off x="1069848" y="5522976"/>
+            <a:ext cx="603504" cy="603504"/>
+          </a:xfrm>
+          <a:prstGeom prst="ellipse">
+            <a:avLst/>
+          </a:prstGeom>
+          <a:solidFill>
+            <a:srgbClr val="F2E5E2"/>
+          </a:solidFill>
+          <a:ln w="12700">
+            <a:solidFill>
+              <a:srgbClr val="F2E5E2"/>
             </a:solidFill>
             <a:prstDash val="solid"/>
           </a:ln>
@@ -17176,7 +18445,7 @@
       </p:sp>
       <p:pic>
         <p:nvPicPr>
-          <p:cNvPr id="8" name="Image 0" descr="/home/andi/Dokumente/Business/Simone Business/Business/fable-andi/pitch/src/assets/andreas.png">    </p:cNvPr>
+          <p:cNvPr id="11" name="Image 0" descr="/home/andi/Dokumente/Business/Simone Business/Business/fable-andi/pitch/src/assets/pain-q.png">    </p:cNvPr>
           <p:cNvPicPr>
             <a:picLocks noChangeAspect="1"/>
           </p:cNvPicPr>
@@ -17190,131 +18459,14 @@
         </p:blipFill>
         <p:spPr>
           <a:xfrm>
-            <a:off x="1389888" y="4663440"/>
-            <a:ext cx="2413045" cy="3246120"/>
+            <a:off x="1097280" y="5550408"/>
+            <a:ext cx="548640" cy="548640"/>
           </a:xfrm>
           <a:prstGeom prst="rect">
             <a:avLst/>
           </a:prstGeom>
         </p:spPr>
       </p:pic>
-      <p:sp>
-        <p:nvSpPr>
-          <p:cNvPr id="9" name="Text 5"/>
-          <p:cNvSpPr txBox="1"/>
-          <p:nvPr/>
-        </p:nvSpPr>
-        <p:spPr>
-          <a:xfrm>
-            <a:off x="4214413" y="5029200"/>
-            <a:ext cx="4408379" cy="274320"/>
-          </a:xfrm>
-          <a:prstGeom prst="rect">
-            <a:avLst/>
-          </a:prstGeom>
-          <a:noFill/>
-          <a:ln/>
-        </p:spPr>
-        <p:txBody>
-          <a:bodyPr wrap="square" lIns="0" tIns="0" rIns="0" bIns="0" rtlCol="0" anchor="t"/>
-          <a:lstStyle/>
-          <a:p>
-            <a:pPr indent="0" marL="0">
-              <a:buNone/>
-            </a:pPr>
-            <a:r>
-              <a:rPr lang="en-US" sz="1050" spc="150" kern="0" dirty="0">
-                <a:solidFill>
-                  <a:srgbClr val="687075"/>
-                </a:solidFill>
-                <a:latin typeface="Poppins" pitchFamily="34" charset="0"/>
-                <a:ea typeface="Poppins" pitchFamily="34" charset="-122"/>
-                <a:cs typeface="Poppins" pitchFamily="34" charset="-120"/>
-              </a:rPr>
-              <a:t>BUILDS THE PRODUCT</a:t>
-            </a:r>
-            <a:endParaRPr lang="en-US" sz="1050" dirty="0"/>
-          </a:p>
-        </p:txBody>
-      </p:sp>
-      <p:sp>
-        <p:nvSpPr>
-          <p:cNvPr id="10" name="Text 6"/>
-          <p:cNvSpPr txBox="1"/>
-          <p:nvPr/>
-        </p:nvSpPr>
-        <p:spPr>
-          <a:xfrm>
-            <a:off x="4214413" y="5303520"/>
-            <a:ext cx="4408379" cy="457200"/>
-          </a:xfrm>
-          <a:prstGeom prst="rect">
-            <a:avLst/>
-          </a:prstGeom>
-          <a:noFill/>
-          <a:ln/>
-        </p:spPr>
-        <p:txBody>
-          <a:bodyPr wrap="square" lIns="0" tIns="0" rIns="0" bIns="0" rtlCol="0" anchor="t"/>
-          <a:lstStyle/>
-          <a:p>
-            <a:pPr indent="0" marL="0">
-              <a:buNone/>
-            </a:pPr>
-            <a:r>
-              <a:rPr lang="en-US" sz="2200" b="1" dirty="0">
-                <a:solidFill>
-                  <a:srgbClr val="171717"/>
-                </a:solidFill>
-                <a:latin typeface="Poppins" pitchFamily="34" charset="0"/>
-                <a:ea typeface="Poppins" pitchFamily="34" charset="-122"/>
-                <a:cs typeface="Poppins" pitchFamily="34" charset="-120"/>
-              </a:rPr>
-              <a:t>ANDREAS HERZINGER</a:t>
-            </a:r>
-            <a:endParaRPr lang="en-US" sz="2200" dirty="0"/>
-          </a:p>
-        </p:txBody>
-      </p:sp>
-      <p:sp>
-        <p:nvSpPr>
-          <p:cNvPr id="11" name="Text 7"/>
-          <p:cNvSpPr txBox="1"/>
-          <p:nvPr/>
-        </p:nvSpPr>
-        <p:spPr>
-          <a:xfrm>
-            <a:off x="4214413" y="5760720"/>
-            <a:ext cx="4408379" cy="320040"/>
-          </a:xfrm>
-          <a:prstGeom prst="rect">
-            <a:avLst/>
-          </a:prstGeom>
-          <a:noFill/>
-          <a:ln/>
-        </p:spPr>
-        <p:txBody>
-          <a:bodyPr wrap="square" lIns="0" tIns="0" rIns="0" bIns="0" rtlCol="0" anchor="t"/>
-          <a:lstStyle/>
-          <a:p>
-            <a:pPr indent="0" marL="0">
-              <a:buNone/>
-            </a:pPr>
-            <a:r>
-              <a:rPr lang="en-US" sz="1350" b="1" dirty="0">
-                <a:solidFill>
-                  <a:srgbClr val="315D66"/>
-                </a:solidFill>
-                <a:latin typeface="Poppins" pitchFamily="34" charset="0"/>
-                <a:ea typeface="Poppins" pitchFamily="34" charset="-122"/>
-                <a:cs typeface="Poppins" pitchFamily="34" charset="-120"/>
-              </a:rPr>
-              <a:t>Product &amp; engineering</a:t>
-            </a:r>
-            <a:endParaRPr lang="en-US" sz="1350" dirty="0"/>
-          </a:p>
-        </p:txBody>
-      </p:sp>
       <p:sp>
         <p:nvSpPr>
           <p:cNvPr id="12" name="Text 8"/>
@@ -17323,8 +18475,8 @@
         </p:nvSpPr>
         <p:spPr>
           <a:xfrm>
-            <a:off x="4214413" y="6172200"/>
-            <a:ext cx="4408379" cy="1737360"/>
+            <a:off x="1938528" y="5440680"/>
+            <a:ext cx="7498080" cy="384048"/>
           </a:xfrm>
           <a:prstGeom prst="rect">
             <a:avLst/>
@@ -17337,13 +18489,49 @@
           <a:lstStyle/>
           <a:p>
             <a:pPr indent="0" marL="0">
-              <a:lnSpc>
-                <a:spcPct val="108000"/>
-              </a:lnSpc>
-              <a:buNone/>
-            </a:pPr>
-            <a:r>
-              <a:rPr lang="en-US" sz="1450" dirty="0">
+              <a:buNone/>
+            </a:pPr>
+            <a:r>
+              <a:rPr lang="en-US" sz="1800" b="1" dirty="0">
+                <a:solidFill>
+                  <a:srgbClr val="171717"/>
+                </a:solidFill>
+                <a:latin typeface="Poppins" pitchFamily="34" charset="0"/>
+                <a:ea typeface="Poppins" pitchFamily="34" charset="-122"/>
+                <a:cs typeface="Poppins" pitchFamily="34" charset="-120"/>
+              </a:rPr>
+              <a:t>QUESTIONNAIRES</a:t>
+            </a:r>
+            <a:endParaRPr lang="en-US" sz="1800" dirty="0"/>
+          </a:p>
+        </p:txBody>
+      </p:sp>
+      <p:sp>
+        <p:nvSpPr>
+          <p:cNvPr id="13" name="Text 9"/>
+          <p:cNvSpPr txBox="1"/>
+          <p:nvPr/>
+        </p:nvSpPr>
+        <p:spPr>
+          <a:xfrm>
+            <a:off x="1938528" y="5824728"/>
+            <a:ext cx="7498080" cy="365760"/>
+          </a:xfrm>
+          <a:prstGeom prst="rect">
+            <a:avLst/>
+          </a:prstGeom>
+          <a:noFill/>
+          <a:ln/>
+        </p:spPr>
+        <p:txBody>
+          <a:bodyPr wrap="square" lIns="0" tIns="0" rIns="0" bIns="0" rtlCol="0" anchor="t"/>
+          <a:lstStyle/>
+          <a:p>
+            <a:pPr indent="0" marL="0">
+              <a:buNone/>
+            </a:pPr>
+            <a:r>
+              <a:rPr lang="en-US" sz="1400" dirty="0">
                 <a:solidFill>
                   <a:srgbClr val="3B3E3C"/>
                 </a:solidFill>
@@ -17351,34 +18539,55 @@
                 <a:ea typeface="Poppins" pitchFamily="34" charset="-122"/>
                 <a:cs typeface="Poppins" pitchFamily="34" charset="-120"/>
               </a:rPr>
-              <a:t>Builds AI integrations for companies: secure connectors, data to LLM, RAG in production. Has seen how compliance turns every integration into a legal question. The evidence graph is his craft.</a:t>
-            </a:r>
-            <a:endParaRPr lang="en-US" sz="1450" dirty="0"/>
-          </a:p>
-        </p:txBody>
-      </p:sp>
-      <p:sp>
-        <p:nvSpPr>
-          <p:cNvPr id="13" name="Shape 9"/>
-          <p:cNvSpPr/>
-          <p:nvPr/>
-        </p:nvSpPr>
-        <p:spPr>
-          <a:xfrm>
-            <a:off x="9354312" y="4343400"/>
-            <a:ext cx="7918704" cy="3886200"/>
-          </a:xfrm>
-          <a:prstGeom prst="roundRect">
-            <a:avLst>
-              <a:gd name="adj" fmla="val 4706"/>
-            </a:avLst>
-          </a:prstGeom>
-          <a:solidFill>
-            <a:srgbClr val="FFFFFF"/>
-          </a:solidFill>
+              <a:t>Answers from memory</a:t>
+            </a:r>
+            <a:endParaRPr lang="en-US" sz="1400" dirty="0"/>
+          </a:p>
+        </p:txBody>
+      </p:sp>
+      <p:sp>
+        <p:nvSpPr>
+          <p:cNvPr id="14" name="Shape 10"/>
+          <p:cNvSpPr/>
+          <p:nvPr/>
+        </p:nvSpPr>
+        <p:spPr>
+          <a:xfrm>
+            <a:off x="1069848" y="6419088"/>
+            <a:ext cx="8412480" cy="0"/>
+          </a:xfrm>
+          <a:prstGeom prst="line">
+            <a:avLst/>
+          </a:prstGeom>
+          <a:noFill/>
           <a:ln w="9525">
             <a:solidFill>
               <a:srgbClr val="DADBD6"/>
+            </a:solidFill>
+            <a:prstDash val="solid"/>
+          </a:ln>
+        </p:spPr>
+      </p:sp>
+      <p:sp>
+        <p:nvSpPr>
+          <p:cNvPr id="15" name="Shape 11"/>
+          <p:cNvSpPr/>
+          <p:nvPr/>
+        </p:nvSpPr>
+        <p:spPr>
+          <a:xfrm>
+            <a:off x="1069848" y="6711696"/>
+            <a:ext cx="603504" cy="603504"/>
+          </a:xfrm>
+          <a:prstGeom prst="ellipse">
+            <a:avLst/>
+          </a:prstGeom>
+          <a:solidFill>
+            <a:srgbClr val="F2E5E2"/>
+          </a:solidFill>
+          <a:ln w="12700">
+            <a:solidFill>
+              <a:srgbClr val="F2E5E2"/>
             </a:solidFill>
             <a:prstDash val="solid"/>
           </a:ln>
@@ -17386,7 +18595,7 @@
       </p:sp>
       <p:pic>
         <p:nvPicPr>
-          <p:cNvPr id="14" name="Image 1" descr="/home/andi/Dokumente/Business/Simone Business/Business/fable-andi/pitch/src/assets/simone.png">    </p:cNvPr>
+          <p:cNvPr id="16" name="Image 1" descr="/home/andi/Dokumente/Business/Simone Business/Business/fable-andi/pitch/src/assets/pain-c.png">    </p:cNvPr>
           <p:cNvPicPr>
             <a:picLocks noChangeAspect="1"/>
           </p:cNvPicPr>
@@ -17400,92 +18609,14 @@
         </p:blipFill>
         <p:spPr>
           <a:xfrm>
-            <a:off x="9674352" y="4663440"/>
-            <a:ext cx="2413045" cy="3246120"/>
+            <a:off x="1097280" y="6739128"/>
+            <a:ext cx="548640" cy="548640"/>
           </a:xfrm>
           <a:prstGeom prst="rect">
             <a:avLst/>
           </a:prstGeom>
         </p:spPr>
       </p:pic>
-      <p:sp>
-        <p:nvSpPr>
-          <p:cNvPr id="15" name="Text 10"/>
-          <p:cNvSpPr txBox="1"/>
-          <p:nvPr/>
-        </p:nvSpPr>
-        <p:spPr>
-          <a:xfrm>
-            <a:off x="12498877" y="5029200"/>
-            <a:ext cx="4408379" cy="274320"/>
-          </a:xfrm>
-          <a:prstGeom prst="rect">
-            <a:avLst/>
-          </a:prstGeom>
-          <a:noFill/>
-          <a:ln/>
-        </p:spPr>
-        <p:txBody>
-          <a:bodyPr wrap="square" lIns="0" tIns="0" rIns="0" bIns="0" rtlCol="0" anchor="t"/>
-          <a:lstStyle/>
-          <a:p>
-            <a:pPr indent="0" marL="0">
-              <a:buNone/>
-            </a:pPr>
-            <a:r>
-              <a:rPr lang="en-US" sz="1050" spc="150" kern="0" dirty="0">
-                <a:solidFill>
-                  <a:srgbClr val="687075"/>
-                </a:solidFill>
-                <a:latin typeface="Poppins" pitchFamily="34" charset="0"/>
-                <a:ea typeface="Poppins" pitchFamily="34" charset="-122"/>
-                <a:cs typeface="Poppins" pitchFamily="34" charset="-120"/>
-              </a:rPr>
-              <a:t>BUILDS THE MARKET</a:t>
-            </a:r>
-            <a:endParaRPr lang="en-US" sz="1050" dirty="0"/>
-          </a:p>
-        </p:txBody>
-      </p:sp>
-      <p:sp>
-        <p:nvSpPr>
-          <p:cNvPr id="16" name="Text 11"/>
-          <p:cNvSpPr txBox="1"/>
-          <p:nvPr/>
-        </p:nvSpPr>
-        <p:spPr>
-          <a:xfrm>
-            <a:off x="12498877" y="5303520"/>
-            <a:ext cx="4408379" cy="457200"/>
-          </a:xfrm>
-          <a:prstGeom prst="rect">
-            <a:avLst/>
-          </a:prstGeom>
-          <a:noFill/>
-          <a:ln/>
-        </p:spPr>
-        <p:txBody>
-          <a:bodyPr wrap="square" lIns="0" tIns="0" rIns="0" bIns="0" rtlCol="0" anchor="t"/>
-          <a:lstStyle/>
-          <a:p>
-            <a:pPr indent="0" marL="0">
-              <a:buNone/>
-            </a:pPr>
-            <a:r>
-              <a:rPr lang="en-US" sz="2200" b="1" dirty="0">
-                <a:solidFill>
-                  <a:srgbClr val="171717"/>
-                </a:solidFill>
-                <a:latin typeface="Poppins" pitchFamily="34" charset="0"/>
-                <a:ea typeface="Poppins" pitchFamily="34" charset="-122"/>
-                <a:cs typeface="Poppins" pitchFamily="34" charset="-120"/>
-              </a:rPr>
-              <a:t>SIMONE MATTIOLI</a:t>
-            </a:r>
-            <a:endParaRPr lang="en-US" sz="2200" dirty="0"/>
-          </a:p>
-        </p:txBody>
-      </p:sp>
       <p:sp>
         <p:nvSpPr>
           <p:cNvPr id="17" name="Text 12"/>
@@ -17494,8 +18625,8 @@
         </p:nvSpPr>
         <p:spPr>
           <a:xfrm>
-            <a:off x="12498877" y="5760720"/>
-            <a:ext cx="4408379" cy="320040"/>
+            <a:off x="1938528" y="6629400"/>
+            <a:ext cx="7498080" cy="384048"/>
           </a:xfrm>
           <a:prstGeom prst="rect">
             <a:avLst/>
@@ -17511,17 +18642,17 @@
               <a:buNone/>
             </a:pPr>
             <a:r>
-              <a:rPr lang="en-US" sz="1350" b="1" dirty="0">
-                <a:solidFill>
-                  <a:srgbClr val="315D66"/>
-                </a:solidFill>
-                <a:latin typeface="Poppins" pitchFamily="34" charset="0"/>
-                <a:ea typeface="Poppins" pitchFamily="34" charset="-122"/>
-                <a:cs typeface="Poppins" pitchFamily="34" charset="-120"/>
-              </a:rPr>
-              <a:t>AI &amp; product development</a:t>
-            </a:r>
-            <a:endParaRPr lang="en-US" sz="1350" dirty="0"/>
+              <a:rPr lang="en-US" sz="1800" b="1" dirty="0">
+                <a:solidFill>
+                  <a:srgbClr val="171717"/>
+                </a:solidFill>
+                <a:latin typeface="Poppins" pitchFamily="34" charset="0"/>
+                <a:ea typeface="Poppins" pitchFamily="34" charset="-122"/>
+                <a:cs typeface="Poppins" pitchFamily="34" charset="-120"/>
+              </a:rPr>
+              <a:t>STALE EVIDENCE</a:t>
+            </a:r>
+            <a:endParaRPr lang="en-US" sz="1800" dirty="0"/>
           </a:p>
         </p:txBody>
       </p:sp>
@@ -17533,8 +18664,8 @@
         </p:nvSpPr>
         <p:spPr>
           <a:xfrm>
-            <a:off x="12498877" y="6172200"/>
-            <a:ext cx="4408379" cy="1737360"/>
+            <a:off x="1938528" y="7013448"/>
+            <a:ext cx="7498080" cy="365760"/>
           </a:xfrm>
           <a:prstGeom prst="rect">
             <a:avLst/>
@@ -17547,13 +18678,10 @@
           <a:lstStyle/>
           <a:p>
             <a:pPr indent="0" marL="0">
-              <a:lnSpc>
-                <a:spcPct val="108000"/>
-              </a:lnSpc>
-              <a:buNone/>
-            </a:pPr>
-            <a:r>
-              <a:rPr lang="en-US" sz="1450" dirty="0">
+              <a:buNone/>
+            </a:pPr>
+            <a:r>
+              <a:rPr lang="en-US" sz="1400" dirty="0">
                 <a:solidFill>
                   <a:srgbClr val="3B3E3C"/>
                 </a:solidFill>
@@ -17561,9 +18689,9 @@
                 <a:ea typeface="Poppins" pitchFamily="34" charset="-122"/>
                 <a:cs typeface="Poppins" pitchFamily="34" charset="-120"/>
               </a:rPr>
-              <a:t>Customers, partners and discovery. EIT Digital Master School. The first year is interviews, one Dutch firm and two design partners, which is his ground.</a:t>
-            </a:r>
-            <a:endParaRPr lang="en-US" sz="1450" dirty="0"/>
+              <a:t>Gaps go unseen</a:t>
+            </a:r>
+            <a:endParaRPr lang="en-US" sz="1400" dirty="0"/>
           </a:p>
         </p:txBody>
       </p:sp>
@@ -17575,35 +18703,234 @@
         </p:nvSpPr>
         <p:spPr>
           <a:xfrm>
-            <a:off x="1069848" y="8458200"/>
-            <a:ext cx="16203168" cy="868680"/>
+            <a:off x="1069848" y="7607808"/>
+            <a:ext cx="8412480" cy="0"/>
+          </a:xfrm>
+          <a:prstGeom prst="line">
+            <a:avLst/>
+          </a:prstGeom>
+          <a:noFill/>
+          <a:ln w="9525">
+            <a:solidFill>
+              <a:srgbClr val="DADBD6"/>
+            </a:solidFill>
+            <a:prstDash val="solid"/>
+          </a:ln>
+        </p:spPr>
+      </p:sp>
+      <p:sp>
+        <p:nvSpPr>
+          <p:cNvPr id="20" name="Shape 15"/>
+          <p:cNvSpPr/>
+          <p:nvPr/>
+        </p:nvSpPr>
+        <p:spPr>
+          <a:xfrm>
+            <a:off x="1069848" y="7900416"/>
+            <a:ext cx="603504" cy="603504"/>
+          </a:xfrm>
+          <a:prstGeom prst="ellipse">
+            <a:avLst/>
+          </a:prstGeom>
+          <a:solidFill>
+            <a:srgbClr val="F2E5E2"/>
+          </a:solidFill>
+          <a:ln w="12700">
+            <a:solidFill>
+              <a:srgbClr val="F2E5E2"/>
+            </a:solidFill>
+            <a:prstDash val="solid"/>
+          </a:ln>
+        </p:spPr>
+      </p:sp>
+      <p:pic>
+        <p:nvPicPr>
+          <p:cNvPr id="21" name="Image 2" descr="/home/andi/Dokumente/Business/Simone Business/Business/fable-andi/pitch/src/assets/pain-d.png">    </p:cNvPr>
+          <p:cNvPicPr>
+            <a:picLocks noChangeAspect="1"/>
+          </p:cNvPicPr>
+          <p:nvPr/>
+        </p:nvPicPr>
+        <p:blipFill>
+          <a:blip r:embed="rId3"/>
+          <a:stretch>
+            <a:fillRect/>
+          </a:stretch>
+        </p:blipFill>
+        <p:spPr>
+          <a:xfrm>
+            <a:off x="1097280" y="7927848"/>
+            <a:ext cx="548640" cy="548640"/>
+          </a:xfrm>
+          <a:prstGeom prst="rect">
+            <a:avLst/>
+          </a:prstGeom>
+        </p:spPr>
+      </p:pic>
+      <p:sp>
+        <p:nvSpPr>
+          <p:cNvPr id="22" name="Text 16"/>
+          <p:cNvSpPr txBox="1"/>
+          <p:nvPr/>
+        </p:nvSpPr>
+        <p:spPr>
+          <a:xfrm>
+            <a:off x="1938528" y="7818120"/>
+            <a:ext cx="7498080" cy="384048"/>
+          </a:xfrm>
+          <a:prstGeom prst="rect">
+            <a:avLst/>
+          </a:prstGeom>
+          <a:noFill/>
+          <a:ln/>
+        </p:spPr>
+        <p:txBody>
+          <a:bodyPr wrap="square" lIns="0" tIns="0" rIns="0" bIns="0" rtlCol="0" anchor="t"/>
+          <a:lstStyle/>
+          <a:p>
+            <a:pPr indent="0" marL="0">
+              <a:buNone/>
+            </a:pPr>
+            <a:r>
+              <a:rPr lang="en-US" sz="1800" b="1" dirty="0">
+                <a:solidFill>
+                  <a:srgbClr val="171717"/>
+                </a:solidFill>
+                <a:latin typeface="Poppins" pitchFamily="34" charset="0"/>
+                <a:ea typeface="Poppins" pitchFamily="34" charset="-122"/>
+                <a:cs typeface="Poppins" pitchFamily="34" charset="-120"/>
+              </a:rPr>
+              <a:t>LEGAL OVERHEAD</a:t>
+            </a:r>
+            <a:endParaRPr lang="en-US" sz="1800" dirty="0"/>
+          </a:p>
+        </p:txBody>
+      </p:sp>
+      <p:sp>
+        <p:nvSpPr>
+          <p:cNvPr id="23" name="Text 17"/>
+          <p:cNvSpPr txBox="1"/>
+          <p:nvPr/>
+        </p:nvSpPr>
+        <p:spPr>
+          <a:xfrm>
+            <a:off x="1938528" y="8202168"/>
+            <a:ext cx="7498080" cy="365760"/>
+          </a:xfrm>
+          <a:prstGeom prst="rect">
+            <a:avLst/>
+          </a:prstGeom>
+          <a:noFill/>
+          <a:ln/>
+        </p:spPr>
+        <p:txBody>
+          <a:bodyPr wrap="square" lIns="0" tIns="0" rIns="0" bIns="0" rtlCol="0" anchor="t"/>
+          <a:lstStyle/>
+          <a:p>
+            <a:pPr indent="0" marL="0">
+              <a:buNone/>
+            </a:pPr>
+            <a:r>
+              <a:rPr lang="en-US" sz="1400" dirty="0">
+                <a:solidFill>
+                  <a:srgbClr val="3B3E3C"/>
+                </a:solidFill>
+                <a:latin typeface="Poppins" pitchFamily="34" charset="0"/>
+                <a:ea typeface="Poppins" pitchFamily="34" charset="-122"/>
+                <a:cs typeface="Poppins" pitchFamily="34" charset="-120"/>
+              </a:rPr>
+              <a:t>Fact-finding repeats</a:t>
+            </a:r>
+            <a:endParaRPr lang="en-US" sz="1400" dirty="0"/>
+          </a:p>
+        </p:txBody>
+      </p:sp>
+      <p:sp>
+        <p:nvSpPr>
+          <p:cNvPr id="24" name="Shape 18"/>
+          <p:cNvSpPr/>
+          <p:nvPr/>
+        </p:nvSpPr>
+        <p:spPr>
+          <a:xfrm>
+            <a:off x="9848088" y="7013448"/>
+            <a:ext cx="731520" cy="0"/>
+          </a:xfrm>
+          <a:prstGeom prst="line">
+            <a:avLst/>
+          </a:prstGeom>
+          <a:noFill/>
+          <a:ln w="38100">
+            <a:solidFill>
+              <a:srgbClr val="497078"/>
+            </a:solidFill>
+            <a:prstDash val="solid"/>
+            <a:tailEnd type="triangle"/>
+          </a:ln>
+        </p:spPr>
+      </p:sp>
+      <p:sp>
+        <p:nvSpPr>
+          <p:cNvPr id="25" name="Shape 19"/>
+          <p:cNvSpPr/>
+          <p:nvPr/>
+        </p:nvSpPr>
+        <p:spPr>
+          <a:xfrm>
+            <a:off x="10945368" y="4572000"/>
+            <a:ext cx="6327648" cy="4224528"/>
           </a:xfrm>
           <a:prstGeom prst="roundRect">
             <a:avLst>
-              <a:gd name="adj" fmla="val 16842"/>
+              <a:gd name="adj" fmla="val 4762"/>
             </a:avLst>
           </a:prstGeom>
           <a:solidFill>
-            <a:srgbClr val="171717"/>
+            <a:srgbClr val="E8F2F2"/>
           </a:solidFill>
           <a:ln w="9525">
             <a:solidFill>
-              <a:srgbClr val="171717"/>
-            </a:solidFill>
-            <a:prstDash val="solid"/>
-          </a:ln>
-        </p:spPr>
-      </p:sp>
-      <p:sp>
-        <p:nvSpPr>
-          <p:cNvPr id="20" name="Text 15"/>
+              <a:srgbClr val="E8F2F2"/>
+            </a:solidFill>
+            <a:prstDash val="solid"/>
+          </a:ln>
+        </p:spPr>
+      </p:sp>
+      <p:sp>
+        <p:nvSpPr>
+          <p:cNvPr id="26" name="Shape 20"/>
+          <p:cNvSpPr/>
+          <p:nvPr/>
+        </p:nvSpPr>
+        <p:spPr>
+          <a:xfrm>
+            <a:off x="11356848" y="5001768"/>
+            <a:ext cx="201168" cy="201168"/>
+          </a:xfrm>
+          <a:prstGeom prst="ellipse">
+            <a:avLst/>
+          </a:prstGeom>
+          <a:solidFill>
+            <a:srgbClr val="497078"/>
+          </a:solidFill>
+          <a:ln w="19050">
+            <a:solidFill>
+              <a:srgbClr val="B9D4D8"/>
+            </a:solidFill>
+            <a:prstDash val="solid"/>
+          </a:ln>
+        </p:spPr>
+      </p:sp>
+      <p:sp>
+        <p:nvSpPr>
+          <p:cNvPr id="27" name="Text 21"/>
           <p:cNvSpPr txBox="1"/>
           <p:nvPr/>
         </p:nvSpPr>
         <p:spPr>
           <a:xfrm>
-            <a:off x="1389888" y="8458200"/>
-            <a:ext cx="2011680" cy="868680"/>
+            <a:off x="11676888" y="4937760"/>
+            <a:ext cx="2743200" cy="329184"/>
           </a:xfrm>
           <a:prstGeom prst="rect">
             <a:avLst/>
@@ -17612,7 +18939,7 @@
           <a:ln/>
         </p:spPr>
         <p:txBody>
-          <a:bodyPr wrap="square" lIns="0" tIns="0" rIns="0" bIns="0" rtlCol="0" anchor="ctr"/>
+          <a:bodyPr wrap="square" lIns="0" tIns="0" rIns="0" bIns="0" rtlCol="0" anchor="t"/>
           <a:lstStyle/>
           <a:p>
             <a:pPr indent="0" marL="0">
@@ -17621,13 +18948,13 @@
             <a:r>
               <a:rPr lang="en-US" sz="1050" b="1" spc="150" kern="0" dirty="0">
                 <a:solidFill>
-                  <a:srgbClr val="B9C4C2"/>
-                </a:solidFill>
-                <a:latin typeface="Poppins" pitchFamily="34" charset="0"/>
-                <a:ea typeface="Poppins" pitchFamily="34" charset="-122"/>
-                <a:cs typeface="Poppins" pitchFamily="34" charset="-120"/>
-              </a:rPr>
-              <a:t>WHY WE DO IT</a:t>
+                  <a:srgbClr val="315D66"/>
+                </a:solidFill>
+                <a:latin typeface="Poppins" pitchFamily="34" charset="0"/>
+                <a:ea typeface="Poppins" pitchFamily="34" charset="-122"/>
+                <a:cs typeface="Poppins" pitchFamily="34" charset="-120"/>
+              </a:rPr>
+              <a:t>REGULIFT</a:t>
             </a:r>
             <a:endParaRPr lang="en-US" sz="1050" dirty="0"/>
           </a:p>
@@ -17635,14 +18962,14 @@
       </p:sp>
       <p:sp>
         <p:nvSpPr>
-          <p:cNvPr id="21" name="Text 16"/>
+          <p:cNvPr id="28" name="Text 22"/>
           <p:cNvSpPr txBox="1"/>
           <p:nvPr/>
         </p:nvSpPr>
         <p:spPr>
           <a:xfrm>
-            <a:off x="3447288" y="8458200"/>
-            <a:ext cx="13551408" cy="868680"/>
+            <a:off x="11356848" y="5440680"/>
+            <a:ext cx="5504688" cy="2103120"/>
           </a:xfrm>
           <a:prstGeom prst="rect">
             <a:avLst/>
@@ -17651,24 +18978,120 @@
           <a:ln/>
         </p:spPr>
         <p:txBody>
-          <a:bodyPr wrap="square" lIns="0" tIns="0" rIns="0" bIns="0" rtlCol="0" anchor="ctr"/>
-          <a:lstStyle/>
-          <a:p>
-            <a:pPr indent="0" marL="0">
-              <a:buNone/>
-            </a:pPr>
-            <a:r>
-              <a:rPr lang="en-US" sz="1450" dirty="0">
-                <a:solidFill>
-                  <a:srgbClr val="FFFFFF"/>
-                </a:solidFill>
-                <a:latin typeface="Poppins" pitchFamily="34" charset="0"/>
-                <a:ea typeface="Poppins" pitchFamily="34" charset="-122"/>
-                <a:cs typeface="Poppins" pitchFamily="34" charset="-120"/>
-              </a:rPr>
-              <a:t>We are a European generation that wants to bring something forward. Cheaper compliance makes Europe's companies more competitive, and we bring the professional experience to make it happen.</a:t>
-            </a:r>
-            <a:endParaRPr lang="en-US" sz="1450" dirty="0"/>
+          <a:bodyPr wrap="square" lIns="0" tIns="0" rIns="0" bIns="0" rtlCol="0" anchor="t"/>
+          <a:lstStyle/>
+          <a:p>
+            <a:pPr indent="0" marL="0">
+              <a:lnSpc>
+                <a:spcPct val="105000"/>
+              </a:lnSpc>
+              <a:buNone/>
+            </a:pPr>
+            <a:r>
+              <a:rPr lang="en-US" sz="2600" b="1" spc="-50" kern="0" dirty="0">
+                <a:solidFill>
+                  <a:srgbClr val="497078"/>
+                </a:solidFill>
+                <a:latin typeface="Poppins" pitchFamily="34" charset="0"/>
+                <a:ea typeface="Poppins" pitchFamily="34" charset="-122"/>
+                <a:cs typeface="Poppins" pitchFamily="34" charset="-120"/>
+              </a:rPr>
+              <a:t>AI-first compliance: </a:t>
+            </a:r>
+            <a:pPr indent="0" marL="0">
+              <a:lnSpc>
+                <a:spcPct val="105000"/>
+              </a:lnSpc>
+              <a:buNone/>
+            </a:pPr>
+            <a:r>
+              <a:rPr lang="en-US" sz="2600" b="1" spc="-50" kern="0" dirty="0">
+                <a:solidFill>
+                  <a:srgbClr val="171717"/>
+                </a:solidFill>
+                <a:latin typeface="Poppins" pitchFamily="34" charset="0"/>
+                <a:ea typeface="Poppins" pitchFamily="34" charset="-122"/>
+                <a:cs typeface="Poppins" pitchFamily="34" charset="-120"/>
+              </a:rPr>
+              <a:t>the facts come from your systems, not from questionnaires.</a:t>
+            </a:r>
+            <a:endParaRPr lang="en-US" sz="2600" dirty="0"/>
+          </a:p>
+        </p:txBody>
+      </p:sp>
+      <p:sp>
+        <p:nvSpPr>
+          <p:cNvPr id="29" name="Shape 23"/>
+          <p:cNvSpPr/>
+          <p:nvPr/>
+        </p:nvSpPr>
+        <p:spPr>
+          <a:xfrm>
+            <a:off x="11356848" y="7882128"/>
+            <a:ext cx="5504688" cy="0"/>
+          </a:xfrm>
+          <a:prstGeom prst="line">
+            <a:avLst/>
+          </a:prstGeom>
+          <a:noFill/>
+          <a:ln w="9525">
+            <a:solidFill>
+              <a:srgbClr val="C9DCDE"/>
+            </a:solidFill>
+            <a:prstDash val="solid"/>
+          </a:ln>
+        </p:spPr>
+      </p:sp>
+      <p:sp>
+        <p:nvSpPr>
+          <p:cNvPr id="30" name="Text 24"/>
+          <p:cNvSpPr txBox="1"/>
+          <p:nvPr/>
+        </p:nvSpPr>
+        <p:spPr>
+          <a:xfrm>
+            <a:off x="11356848" y="8019288"/>
+            <a:ext cx="5504688" cy="411480"/>
+          </a:xfrm>
+          <a:prstGeom prst="rect">
+            <a:avLst/>
+          </a:prstGeom>
+          <a:noFill/>
+          <a:ln/>
+        </p:spPr>
+        <p:txBody>
+          <a:bodyPr wrap="square" lIns="0" tIns="0" rIns="0" bIns="0" rtlCol="0" anchor="t"/>
+          <a:lstStyle/>
+          <a:p>
+            <a:pPr indent="0" marL="0">
+              <a:buNone/>
+            </a:pPr>
+            <a:r>
+              <a:rPr lang="en-US" sz="1300" b="1" dirty="0">
+                <a:solidFill>
+                  <a:srgbClr val="315D66"/>
+                </a:solidFill>
+                <a:latin typeface="Poppins" pitchFamily="34" charset="0"/>
+                <a:ea typeface="Poppins" pitchFamily="34" charset="-122"/>
+                <a:cs typeface="Poppins" pitchFamily="34" charset="-120"/>
+              </a:rPr>
+              <a:t>Next: </a:t>
+            </a:r>
+            <a:pPr indent="0" marL="0">
+              <a:buNone/>
+            </a:pPr>
+            <a:r>
+              <a:rPr lang="en-US" sz="1300" dirty="0">
+                <a:solidFill>
+                  <a:srgbClr val="4A5E62"/>
+                </a:solidFill>
+                <a:latin typeface="Poppins" pitchFamily="34" charset="0"/>
+                <a:ea typeface="Poppins" pitchFamily="34" charset="-122"/>
+                <a:cs typeface="Poppins" pitchFamily="34" charset="-120"/>
+              </a:rPr>
+              <a:t>the inside out framework.</a:t>
+            </a:r>
+            <a:endParaRPr lang="en-US" sz="1300" dirty="0"/>
           </a:p>
         </p:txBody>
       </p:sp>

</xml_diff>